<commit_message>
21.03 various images and graphs
</commit_message>
<xml_diff>
--- a/home-made-diagrams/16.3 homebrew-diagrams.pptx
+++ b/home-made-diagrams/16.3 homebrew-diagrams.pptx
@@ -7,6 +7,7 @@
   <p:sldIdLst>
     <p:sldId id="256" r:id="rId2"/>
     <p:sldId id="257" r:id="rId3"/>
+    <p:sldId id="258" r:id="rId4"/>
   </p:sldIdLst>
   <p:sldSz cx="12192000" cy="6858000"/>
   <p:notesSz cx="6858000" cy="9144000"/>
@@ -3373,8 +3374,8 @@
         </p:nvSpPr>
         <p:spPr>
           <a:xfrm>
-            <a:off x="1828800" y="1190625"/>
-            <a:ext cx="2724150" cy="2724150"/>
+            <a:off x="1243886" y="1269185"/>
+            <a:ext cx="1615806" cy="1615806"/>
           </a:xfrm>
           <a:prstGeom prst="ellipse">
             <a:avLst/>
@@ -3425,8 +3426,8 @@
         </p:nvSpPr>
         <p:spPr>
           <a:xfrm>
-            <a:off x="4733925" y="1190625"/>
-            <a:ext cx="2724150" cy="2724150"/>
+            <a:off x="3815556" y="1269185"/>
+            <a:ext cx="1615806" cy="1615806"/>
           </a:xfrm>
           <a:prstGeom prst="ellipse">
             <a:avLst/>
@@ -3477,8 +3478,8 @@
         </p:nvSpPr>
         <p:spPr>
           <a:xfrm>
-            <a:off x="7639050" y="1181100"/>
-            <a:ext cx="2724150" cy="2724150"/>
+            <a:off x="6530862" y="1276102"/>
+            <a:ext cx="1615806" cy="1615806"/>
           </a:xfrm>
           <a:prstGeom prst="ellipse">
             <a:avLst/>
@@ -3529,8 +3530,8 @@
         </p:nvSpPr>
         <p:spPr>
           <a:xfrm>
-            <a:off x="1828800" y="2943225"/>
-            <a:ext cx="2724150" cy="2724150"/>
+            <a:off x="1215771" y="4280584"/>
+            <a:ext cx="1615806" cy="1615806"/>
           </a:xfrm>
           <a:prstGeom prst="ellipse">
             <a:avLst/>
@@ -3584,8 +3585,8 @@
         </p:nvSpPr>
         <p:spPr>
           <a:xfrm>
-            <a:off x="4733925" y="2943225"/>
-            <a:ext cx="2724150" cy="2724150"/>
+            <a:off x="3815555" y="4280584"/>
+            <a:ext cx="1615806" cy="1615806"/>
           </a:xfrm>
           <a:prstGeom prst="ellipse">
             <a:avLst/>
@@ -3639,8 +3640,8 @@
         </p:nvSpPr>
         <p:spPr>
           <a:xfrm>
-            <a:off x="7639050" y="2933700"/>
-            <a:ext cx="2724150" cy="2724150"/>
+            <a:off x="6530862" y="4280584"/>
+            <a:ext cx="1615806" cy="1615806"/>
           </a:xfrm>
           <a:prstGeom prst="ellipse">
             <a:avLst/>
@@ -3694,8 +3695,8 @@
         </p:nvSpPr>
         <p:spPr>
           <a:xfrm>
-            <a:off x="2156745" y="495300"/>
-            <a:ext cx="2068259" cy="461665"/>
+            <a:off x="1444603" y="1594969"/>
+            <a:ext cx="1214371" cy="830997"/>
           </a:xfrm>
           <a:prstGeom prst="rect">
             <a:avLst/>
@@ -3708,9 +3709,24 @@
           </a:bodyPr>
           <a:lstStyle/>
           <a:p>
-            <a:r>
-              <a:rPr lang="en-NZ" sz="2400" dirty="0"/>
-              <a:t>1. Attachment</a:t>
+            <a:pPr algn="ctr"/>
+            <a:r>
+              <a:rPr lang="en-NZ" sz="1600" dirty="0"/>
+              <a:t>1.</a:t>
+            </a:r>
+          </a:p>
+          <a:p>
+            <a:pPr algn="ctr"/>
+            <a:r>
+              <a:rPr lang="en-NZ" sz="1600" dirty="0"/>
+              <a:t>Reversible</a:t>
+            </a:r>
+          </a:p>
+          <a:p>
+            <a:pPr algn="ctr"/>
+            <a:r>
+              <a:rPr lang="en-NZ" sz="1600" dirty="0"/>
+              <a:t>attachment</a:t>
             </a:r>
           </a:p>
         </p:txBody>
@@ -3729,8 +3745,8 @@
         </p:nvSpPr>
         <p:spPr>
           <a:xfrm>
-            <a:off x="5124484" y="495300"/>
-            <a:ext cx="1943032" cy="461665"/>
+            <a:off x="3835230" y="1369202"/>
+            <a:ext cx="1576457" cy="1077218"/>
           </a:xfrm>
           <a:prstGeom prst="rect">
             <a:avLst/>
@@ -3743,9 +3759,31 @@
           </a:bodyPr>
           <a:lstStyle/>
           <a:p>
-            <a:r>
-              <a:rPr lang="en-NZ" sz="2400" dirty="0"/>
-              <a:t>2. Maturation</a:t>
+            <a:pPr algn="ctr"/>
+            <a:r>
+              <a:rPr lang="en-NZ" sz="1600" dirty="0"/>
+              <a:t>2.</a:t>
+            </a:r>
+          </a:p>
+          <a:p>
+            <a:pPr algn="ctr"/>
+            <a:r>
+              <a:rPr lang="en-NZ" sz="1600" dirty="0"/>
+              <a:t>Irreversible</a:t>
+            </a:r>
+          </a:p>
+          <a:p>
+            <a:pPr algn="ctr"/>
+            <a:r>
+              <a:rPr lang="en-NZ" sz="1600" dirty="0"/>
+              <a:t>attachment</a:t>
+            </a:r>
+          </a:p>
+          <a:p>
+            <a:pPr algn="ctr"/>
+            <a:r>
+              <a:rPr lang="en-NZ" sz="1600" dirty="0"/>
+              <a:t>(microcolonies)</a:t>
             </a:r>
           </a:p>
         </p:txBody>
@@ -3764,8 +3802,8 @@
         </p:nvSpPr>
         <p:spPr>
           <a:xfrm>
-            <a:off x="7998831" y="495299"/>
-            <a:ext cx="2004588" cy="461665"/>
+            <a:off x="6764761" y="1718079"/>
+            <a:ext cx="1148007" cy="584775"/>
           </a:xfrm>
           <a:prstGeom prst="rect">
             <a:avLst/>
@@ -3778,9 +3816,561 @@
           </a:bodyPr>
           <a:lstStyle/>
           <a:p>
-            <a:r>
-              <a:rPr lang="en-NZ" sz="2400" dirty="0"/>
-              <a:t>3. Dissipation</a:t>
+            <a:pPr algn="ctr"/>
+            <a:r>
+              <a:rPr lang="en-NZ" sz="1600" dirty="0"/>
+              <a:t>3.</a:t>
+            </a:r>
+          </a:p>
+          <a:p>
+            <a:pPr algn="ctr"/>
+            <a:r>
+              <a:rPr lang="en-NZ" sz="1600" dirty="0"/>
+              <a:t>Maturation</a:t>
+            </a:r>
+          </a:p>
+        </p:txBody>
+      </p:sp>
+      <p:sp>
+        <p:nvSpPr>
+          <p:cNvPr id="2" name="Oval 1">
+            <a:extLst>
+              <a:ext uri="{FF2B5EF4-FFF2-40B4-BE49-F238E27FC236}">
+                <a16:creationId xmlns:a16="http://schemas.microsoft.com/office/drawing/2014/main" id="{3154398F-7386-059A-55DB-A2D0B5D61644}"/>
+              </a:ext>
+            </a:extLst>
+          </p:cNvPr>
+          <p:cNvSpPr/>
+          <p:nvPr/>
+        </p:nvSpPr>
+        <p:spPr>
+          <a:xfrm>
+            <a:off x="9164738" y="1276102"/>
+            <a:ext cx="1615806" cy="1615806"/>
+          </a:xfrm>
+          <a:prstGeom prst="ellipse">
+            <a:avLst/>
+          </a:prstGeom>
+          <a:noFill/>
+          <a:ln w="57150">
+            <a:solidFill>
+              <a:schemeClr val="accent5"/>
+            </a:solidFill>
+          </a:ln>
+        </p:spPr>
+        <p:style>
+          <a:lnRef idx="2">
+            <a:schemeClr val="accent1">
+              <a:shade val="15000"/>
+            </a:schemeClr>
+          </a:lnRef>
+          <a:fillRef idx="1">
+            <a:schemeClr val="accent1"/>
+          </a:fillRef>
+          <a:effectRef idx="0">
+            <a:schemeClr val="accent1"/>
+          </a:effectRef>
+          <a:fontRef idx="minor">
+            <a:schemeClr val="lt1"/>
+          </a:fontRef>
+        </p:style>
+        <p:txBody>
+          <a:bodyPr rtlCol="0" anchor="ctr"/>
+          <a:lstStyle/>
+          <a:p>
+            <a:pPr algn="ctr"/>
+            <a:endParaRPr lang="en-NZ"/>
+          </a:p>
+        </p:txBody>
+      </p:sp>
+      <p:sp>
+        <p:nvSpPr>
+          <p:cNvPr id="3" name="Oval 2">
+            <a:extLst>
+              <a:ext uri="{FF2B5EF4-FFF2-40B4-BE49-F238E27FC236}">
+                <a16:creationId xmlns:a16="http://schemas.microsoft.com/office/drawing/2014/main" id="{CBF97914-B2F8-2055-F760-133A0C50405E}"/>
+              </a:ext>
+            </a:extLst>
+          </p:cNvPr>
+          <p:cNvSpPr/>
+          <p:nvPr/>
+        </p:nvSpPr>
+        <p:spPr>
+          <a:xfrm>
+            <a:off x="9164738" y="4280584"/>
+            <a:ext cx="1615806" cy="1615806"/>
+          </a:xfrm>
+          <a:prstGeom prst="ellipse">
+            <a:avLst/>
+          </a:prstGeom>
+          <a:noFill/>
+          <a:ln w="57150">
+            <a:solidFill>
+              <a:schemeClr val="accent5">
+                <a:lumMod val="40000"/>
+                <a:lumOff val="60000"/>
+              </a:schemeClr>
+            </a:solidFill>
+          </a:ln>
+        </p:spPr>
+        <p:style>
+          <a:lnRef idx="2">
+            <a:schemeClr val="accent1">
+              <a:shade val="15000"/>
+            </a:schemeClr>
+          </a:lnRef>
+          <a:fillRef idx="1">
+            <a:schemeClr val="accent1"/>
+          </a:fillRef>
+          <a:effectRef idx="0">
+            <a:schemeClr val="accent1"/>
+          </a:effectRef>
+          <a:fontRef idx="minor">
+            <a:schemeClr val="lt1"/>
+          </a:fontRef>
+        </p:style>
+        <p:txBody>
+          <a:bodyPr rtlCol="0" anchor="ctr"/>
+          <a:lstStyle/>
+          <a:p>
+            <a:pPr algn="ctr"/>
+            <a:endParaRPr lang="en-NZ"/>
+          </a:p>
+        </p:txBody>
+      </p:sp>
+      <p:sp>
+        <p:nvSpPr>
+          <p:cNvPr id="15" name="TextBox 14">
+            <a:extLst>
+              <a:ext uri="{FF2B5EF4-FFF2-40B4-BE49-F238E27FC236}">
+                <a16:creationId xmlns:a16="http://schemas.microsoft.com/office/drawing/2014/main" id="{5831E1B0-606E-7C5F-E3AB-9675BDDBDDC9}"/>
+              </a:ext>
+            </a:extLst>
+          </p:cNvPr>
+          <p:cNvSpPr txBox="1"/>
+          <p:nvPr/>
+        </p:nvSpPr>
+        <p:spPr>
+          <a:xfrm>
+            <a:off x="9377863" y="1718078"/>
+            <a:ext cx="1189556" cy="584775"/>
+          </a:xfrm>
+          <a:prstGeom prst="rect">
+            <a:avLst/>
+          </a:prstGeom>
+          <a:noFill/>
+        </p:spPr>
+        <p:txBody>
+          <a:bodyPr wrap="none" rtlCol="0">
+            <a:spAutoFit/>
+          </a:bodyPr>
+          <a:lstStyle/>
+          <a:p>
+            <a:pPr algn="ctr"/>
+            <a:r>
+              <a:rPr lang="en-NZ" sz="1600" dirty="0"/>
+              <a:t>4.</a:t>
+            </a:r>
+          </a:p>
+          <a:p>
+            <a:pPr algn="ctr"/>
+            <a:r>
+              <a:rPr lang="en-NZ" sz="1600" dirty="0"/>
+              <a:t>Dissipation</a:t>
+            </a:r>
+          </a:p>
+        </p:txBody>
+      </p:sp>
+      <p:sp>
+        <p:nvSpPr>
+          <p:cNvPr id="17" name="Rectangle: Rounded Corners 16">
+            <a:extLst>
+              <a:ext uri="{FF2B5EF4-FFF2-40B4-BE49-F238E27FC236}">
+                <a16:creationId xmlns:a16="http://schemas.microsoft.com/office/drawing/2014/main" id="{27BE8332-E929-B4C7-8E62-1E8C99299AAA}"/>
+              </a:ext>
+            </a:extLst>
+          </p:cNvPr>
+          <p:cNvSpPr/>
+          <p:nvPr/>
+        </p:nvSpPr>
+        <p:spPr>
+          <a:xfrm>
+            <a:off x="1114792" y="3108102"/>
+            <a:ext cx="9829366" cy="938150"/>
+          </a:xfrm>
+          <a:prstGeom prst="roundRect">
+            <a:avLst/>
+          </a:prstGeom>
+          <a:noFill/>
+          <a:ln w="38100">
+            <a:solidFill>
+              <a:srgbClr val="002060"/>
+            </a:solidFill>
+          </a:ln>
+        </p:spPr>
+        <p:style>
+          <a:lnRef idx="2">
+            <a:schemeClr val="accent1">
+              <a:shade val="15000"/>
+            </a:schemeClr>
+          </a:lnRef>
+          <a:fillRef idx="1">
+            <a:schemeClr val="accent1"/>
+          </a:fillRef>
+          <a:effectRef idx="0">
+            <a:schemeClr val="accent1"/>
+          </a:effectRef>
+          <a:fontRef idx="minor">
+            <a:schemeClr val="lt1"/>
+          </a:fontRef>
+        </p:style>
+        <p:txBody>
+          <a:bodyPr rtlCol="0" anchor="ctr"/>
+          <a:lstStyle/>
+          <a:p>
+            <a:pPr algn="ctr"/>
+            <a:endParaRPr lang="en-NZ"/>
+          </a:p>
+        </p:txBody>
+      </p:sp>
+      <p:sp>
+        <p:nvSpPr>
+          <p:cNvPr id="18" name="TextBox 17">
+            <a:extLst>
+              <a:ext uri="{FF2B5EF4-FFF2-40B4-BE49-F238E27FC236}">
+                <a16:creationId xmlns:a16="http://schemas.microsoft.com/office/drawing/2014/main" id="{940DA1D7-DD7F-EB0D-089C-32B7CDCEF414}"/>
+              </a:ext>
+            </a:extLst>
+          </p:cNvPr>
+          <p:cNvSpPr txBox="1"/>
+          <p:nvPr/>
+        </p:nvSpPr>
+        <p:spPr>
+          <a:xfrm>
+            <a:off x="4894016" y="3392511"/>
+            <a:ext cx="2406556" cy="369332"/>
+          </a:xfrm>
+          <a:prstGeom prst="rect">
+            <a:avLst/>
+          </a:prstGeom>
+          <a:noFill/>
+        </p:spPr>
+        <p:txBody>
+          <a:bodyPr wrap="none" rtlCol="0">
+            <a:spAutoFit/>
+          </a:bodyPr>
+          <a:lstStyle/>
+          <a:p>
+            <a:r>
+              <a:rPr lang="en-NZ" i="1" dirty="0"/>
+              <a:t>c) Unclassified genes?</a:t>
+            </a:r>
+          </a:p>
+        </p:txBody>
+      </p:sp>
+      <p:sp>
+        <p:nvSpPr>
+          <p:cNvPr id="19" name="TextBox 18">
+            <a:extLst>
+              <a:ext uri="{FF2B5EF4-FFF2-40B4-BE49-F238E27FC236}">
+                <a16:creationId xmlns:a16="http://schemas.microsoft.com/office/drawing/2014/main" id="{7C9BAA7D-54CF-703D-86B3-0A9088D1EFC0}"/>
+              </a:ext>
+            </a:extLst>
+          </p:cNvPr>
+          <p:cNvSpPr txBox="1"/>
+          <p:nvPr/>
+        </p:nvSpPr>
+        <p:spPr>
+          <a:xfrm>
+            <a:off x="11332559" y="4794680"/>
+            <a:ext cx="436594" cy="369332"/>
+          </a:xfrm>
+          <a:prstGeom prst="rect">
+            <a:avLst/>
+          </a:prstGeom>
+          <a:noFill/>
+        </p:spPr>
+        <p:txBody>
+          <a:bodyPr wrap="none" rtlCol="0">
+            <a:spAutoFit/>
+          </a:bodyPr>
+          <a:lstStyle/>
+          <a:p>
+            <a:r>
+              <a:rPr lang="en-NZ" i="1" dirty="0"/>
+              <a:t>Pa</a:t>
+            </a:r>
+          </a:p>
+        </p:txBody>
+      </p:sp>
+      <p:sp>
+        <p:nvSpPr>
+          <p:cNvPr id="20" name="TextBox 19">
+            <a:extLst>
+              <a:ext uri="{FF2B5EF4-FFF2-40B4-BE49-F238E27FC236}">
+                <a16:creationId xmlns:a16="http://schemas.microsoft.com/office/drawing/2014/main" id="{D78F9B9A-AF40-A294-E4AC-CA77167CDD35}"/>
+              </a:ext>
+            </a:extLst>
+          </p:cNvPr>
+          <p:cNvSpPr txBox="1"/>
+          <p:nvPr/>
+        </p:nvSpPr>
+        <p:spPr>
+          <a:xfrm>
+            <a:off x="11331213" y="1892422"/>
+            <a:ext cx="437940" cy="369332"/>
+          </a:xfrm>
+          <a:prstGeom prst="rect">
+            <a:avLst/>
+          </a:prstGeom>
+          <a:noFill/>
+        </p:spPr>
+        <p:txBody>
+          <a:bodyPr wrap="none" rtlCol="0">
+            <a:spAutoFit/>
+          </a:bodyPr>
+          <a:lstStyle/>
+          <a:p>
+            <a:r>
+              <a:rPr lang="en-NZ" i="1" dirty="0"/>
+              <a:t>Sa</a:t>
+            </a:r>
+          </a:p>
+        </p:txBody>
+      </p:sp>
+      <p:cxnSp>
+        <p:nvCxnSpPr>
+          <p:cNvPr id="22" name="Straight Arrow Connector 21">
+            <a:extLst>
+              <a:ext uri="{FF2B5EF4-FFF2-40B4-BE49-F238E27FC236}">
+                <a16:creationId xmlns:a16="http://schemas.microsoft.com/office/drawing/2014/main" id="{69066965-29D5-5BB9-DC3F-89EA6661EADD}"/>
+              </a:ext>
+            </a:extLst>
+          </p:cNvPr>
+          <p:cNvCxnSpPr/>
+          <p:nvPr/>
+        </p:nvCxnSpPr>
+        <p:spPr>
+          <a:xfrm>
+            <a:off x="11551789" y="2528226"/>
+            <a:ext cx="0" cy="1817511"/>
+          </a:xfrm>
+          <a:prstGeom prst="straightConnector1">
+            <a:avLst/>
+          </a:prstGeom>
+          <a:ln w="38100">
+            <a:solidFill>
+              <a:srgbClr val="002060"/>
+            </a:solidFill>
+            <a:headEnd type="triangle"/>
+            <a:tailEnd type="triangle"/>
+          </a:ln>
+        </p:spPr>
+        <p:style>
+          <a:lnRef idx="2">
+            <a:schemeClr val="accent1"/>
+          </a:lnRef>
+          <a:fillRef idx="0">
+            <a:schemeClr val="accent1"/>
+          </a:fillRef>
+          <a:effectRef idx="1">
+            <a:schemeClr val="accent1"/>
+          </a:effectRef>
+          <a:fontRef idx="minor">
+            <a:schemeClr val="tx1"/>
+          </a:fontRef>
+        </p:style>
+      </p:cxnSp>
+      <p:sp>
+        <p:nvSpPr>
+          <p:cNvPr id="23" name="TextBox 22">
+            <a:extLst>
+              <a:ext uri="{FF2B5EF4-FFF2-40B4-BE49-F238E27FC236}">
+                <a16:creationId xmlns:a16="http://schemas.microsoft.com/office/drawing/2014/main" id="{7C6049CC-365A-0ED7-541C-6FF1B02E01F9}"/>
+              </a:ext>
+            </a:extLst>
+          </p:cNvPr>
+          <p:cNvSpPr txBox="1"/>
+          <p:nvPr/>
+        </p:nvSpPr>
+        <p:spPr>
+          <a:xfrm rot="5400000">
+            <a:off x="10823260" y="3307810"/>
+            <a:ext cx="2102242" cy="338554"/>
+          </a:xfrm>
+          <a:prstGeom prst="rect">
+            <a:avLst/>
+          </a:prstGeom>
+          <a:noFill/>
+        </p:spPr>
+        <p:txBody>
+          <a:bodyPr wrap="none" rtlCol="0">
+            <a:spAutoFit/>
+          </a:bodyPr>
+          <a:lstStyle/>
+          <a:p>
+            <a:r>
+              <a:rPr lang="en-NZ" sz="1600" i="1" dirty="0"/>
+              <a:t>b) Strain coevolution?</a:t>
+            </a:r>
+          </a:p>
+        </p:txBody>
+      </p:sp>
+      <p:cxnSp>
+        <p:nvCxnSpPr>
+          <p:cNvPr id="24" name="Straight Arrow Connector 23">
+            <a:extLst>
+              <a:ext uri="{FF2B5EF4-FFF2-40B4-BE49-F238E27FC236}">
+                <a16:creationId xmlns:a16="http://schemas.microsoft.com/office/drawing/2014/main" id="{7F013D25-E6E5-CC3F-5E00-033CF0F546AF}"/>
+              </a:ext>
+            </a:extLst>
+          </p:cNvPr>
+          <p:cNvCxnSpPr>
+            <a:cxnSpLocks/>
+          </p:cNvCxnSpPr>
+          <p:nvPr/>
+        </p:nvCxnSpPr>
+        <p:spPr>
+          <a:xfrm flipH="1">
+            <a:off x="1961877" y="6287426"/>
+            <a:ext cx="8141679" cy="0"/>
+          </a:xfrm>
+          <a:prstGeom prst="straightConnector1">
+            <a:avLst/>
+          </a:prstGeom>
+          <a:ln w="38100">
+            <a:solidFill>
+              <a:srgbClr val="002060"/>
+            </a:solidFill>
+            <a:headEnd type="stealth"/>
+            <a:tailEnd type="none"/>
+          </a:ln>
+        </p:spPr>
+        <p:style>
+          <a:lnRef idx="2">
+            <a:schemeClr val="accent1"/>
+          </a:lnRef>
+          <a:fillRef idx="0">
+            <a:schemeClr val="accent1"/>
+          </a:fillRef>
+          <a:effectRef idx="1">
+            <a:schemeClr val="accent1"/>
+          </a:effectRef>
+          <a:fontRef idx="minor">
+            <a:schemeClr val="tx1"/>
+          </a:fontRef>
+        </p:style>
+      </p:cxnSp>
+      <p:sp>
+        <p:nvSpPr>
+          <p:cNvPr id="28" name="TextBox 27">
+            <a:extLst>
+              <a:ext uri="{FF2B5EF4-FFF2-40B4-BE49-F238E27FC236}">
+                <a16:creationId xmlns:a16="http://schemas.microsoft.com/office/drawing/2014/main" id="{EF7FD21F-EADE-4B5B-DC0A-B2D2DC7C6FF2}"/>
+              </a:ext>
+            </a:extLst>
+          </p:cNvPr>
+          <p:cNvSpPr txBox="1"/>
+          <p:nvPr/>
+        </p:nvSpPr>
+        <p:spPr>
+          <a:xfrm>
+            <a:off x="4681965" y="6389057"/>
+            <a:ext cx="2656799" cy="369332"/>
+          </a:xfrm>
+          <a:prstGeom prst="rect">
+            <a:avLst/>
+          </a:prstGeom>
+          <a:noFill/>
+        </p:spPr>
+        <p:txBody>
+          <a:bodyPr wrap="square">
+            <a:spAutoFit/>
+          </a:bodyPr>
+          <a:lstStyle/>
+          <a:p>
+            <a:pPr algn="ctr"/>
+            <a:r>
+              <a:rPr lang="en-NZ" i="1" dirty="0"/>
+              <a:t>a</a:t>
+            </a:r>
+            <a:r>
+              <a:rPr lang="en-NZ" sz="1800" i="1" dirty="0"/>
+              <a:t>) Parallel development?</a:t>
+            </a:r>
+          </a:p>
+        </p:txBody>
+      </p:sp>
+      <p:cxnSp>
+        <p:nvCxnSpPr>
+          <p:cNvPr id="30" name="Straight Connector 29">
+            <a:extLst>
+              <a:ext uri="{FF2B5EF4-FFF2-40B4-BE49-F238E27FC236}">
+                <a16:creationId xmlns:a16="http://schemas.microsoft.com/office/drawing/2014/main" id="{577B4CBF-33AF-078D-895A-AED1F0B7DEF2}"/>
+              </a:ext>
+            </a:extLst>
+          </p:cNvPr>
+          <p:cNvCxnSpPr/>
+          <p:nvPr/>
+        </p:nvCxnSpPr>
+        <p:spPr>
+          <a:xfrm>
+            <a:off x="3352800" y="1010465"/>
+            <a:ext cx="0" cy="4933244"/>
+          </a:xfrm>
+          <a:prstGeom prst="line">
+            <a:avLst/>
+          </a:prstGeom>
+          <a:ln w="38100">
+            <a:prstDash val="sysDot"/>
+          </a:ln>
+        </p:spPr>
+        <p:style>
+          <a:lnRef idx="2">
+            <a:schemeClr val="accent1"/>
+          </a:lnRef>
+          <a:fillRef idx="0">
+            <a:schemeClr val="accent1"/>
+          </a:fillRef>
+          <a:effectRef idx="1">
+            <a:schemeClr val="accent1"/>
+          </a:effectRef>
+          <a:fontRef idx="minor">
+            <a:schemeClr val="tx1"/>
+          </a:fontRef>
+        </p:style>
+      </p:cxnSp>
+      <p:sp>
+        <p:nvSpPr>
+          <p:cNvPr id="31" name="TextBox 30">
+            <a:extLst>
+              <a:ext uri="{FF2B5EF4-FFF2-40B4-BE49-F238E27FC236}">
+                <a16:creationId xmlns:a16="http://schemas.microsoft.com/office/drawing/2014/main" id="{196EA6B5-F415-583D-28DD-358B191C7F30}"/>
+              </a:ext>
+            </a:extLst>
+          </p:cNvPr>
+          <p:cNvSpPr txBox="1"/>
+          <p:nvPr/>
+        </p:nvSpPr>
+        <p:spPr>
+          <a:xfrm>
+            <a:off x="2023674" y="508817"/>
+            <a:ext cx="2644570" cy="369332"/>
+          </a:xfrm>
+          <a:prstGeom prst="rect">
+            <a:avLst/>
+          </a:prstGeom>
+          <a:noFill/>
+        </p:spPr>
+        <p:txBody>
+          <a:bodyPr wrap="none" rtlCol="0">
+            <a:spAutoFit/>
+          </a:bodyPr>
+          <a:lstStyle/>
+          <a:p>
+            <a:r>
+              <a:rPr lang="en-NZ" i="1" dirty="0"/>
+              <a:t>d) Developmental gates?</a:t>
             </a:r>
           </a:p>
         </p:txBody>
@@ -5510,6 +6100,328 @@
     <p:extLst>
       <p:ext uri="{BB962C8B-B14F-4D97-AF65-F5344CB8AC3E}">
         <p14:creationId xmlns:p14="http://schemas.microsoft.com/office/powerpoint/2010/main" val="2578992580"/>
+      </p:ext>
+    </p:extLst>
+  </p:cSld>
+  <p:clrMapOvr>
+    <a:masterClrMapping/>
+  </p:clrMapOvr>
+</p:sld>
+</file>
+
+<file path=ppt/slides/slide3.xml><?xml version="1.0" encoding="utf-8"?>
+<p:sld xmlns:a="http://schemas.openxmlformats.org/drawingml/2006/main" xmlns:r="http://schemas.openxmlformats.org/officeDocument/2006/relationships" xmlns:p="http://schemas.openxmlformats.org/presentationml/2006/main">
+  <p:cSld>
+    <p:spTree>
+      <p:nvGrpSpPr>
+        <p:cNvPr id="1" name=""/>
+        <p:cNvGrpSpPr/>
+        <p:nvPr/>
+      </p:nvGrpSpPr>
+      <p:grpSpPr>
+        <a:xfrm>
+          <a:off x="0" y="0"/>
+          <a:ext cx="0" cy="0"/>
+          <a:chOff x="0" y="0"/>
+          <a:chExt cx="0" cy="0"/>
+        </a:xfrm>
+      </p:grpSpPr>
+      <p:sp>
+        <p:nvSpPr>
+          <p:cNvPr id="2" name="Arrow: Right 1">
+            <a:extLst>
+              <a:ext uri="{FF2B5EF4-FFF2-40B4-BE49-F238E27FC236}">
+                <a16:creationId xmlns:a16="http://schemas.microsoft.com/office/drawing/2014/main" id="{BA1DE30D-CE9A-6C73-19D9-DA55B177DF8C}"/>
+              </a:ext>
+            </a:extLst>
+          </p:cNvPr>
+          <p:cNvSpPr/>
+          <p:nvPr/>
+        </p:nvSpPr>
+        <p:spPr>
+          <a:xfrm rot="16200000">
+            <a:off x="3610146" y="2102606"/>
+            <a:ext cx="2682625" cy="735189"/>
+          </a:xfrm>
+          <a:prstGeom prst="rightArrow">
+            <a:avLst/>
+          </a:prstGeom>
+          <a:gradFill flip="none" rotWithShape="1">
+            <a:gsLst>
+              <a:gs pos="0">
+                <a:srgbClr val="002060"/>
+              </a:gs>
+              <a:gs pos="74000">
+                <a:schemeClr val="accent1">
+                  <a:lumMod val="45000"/>
+                  <a:lumOff val="55000"/>
+                </a:schemeClr>
+              </a:gs>
+              <a:gs pos="83000">
+                <a:schemeClr val="accent1">
+                  <a:lumMod val="45000"/>
+                  <a:lumOff val="55000"/>
+                </a:schemeClr>
+              </a:gs>
+              <a:gs pos="100000">
+                <a:schemeClr val="accent1">
+                  <a:lumMod val="30000"/>
+                  <a:lumOff val="70000"/>
+                </a:schemeClr>
+              </a:gs>
+            </a:gsLst>
+            <a:lin ang="10800000" scaled="1"/>
+            <a:tileRect/>
+          </a:gradFill>
+        </p:spPr>
+        <p:style>
+          <a:lnRef idx="2">
+            <a:schemeClr val="accent1">
+              <a:shade val="15000"/>
+            </a:schemeClr>
+          </a:lnRef>
+          <a:fillRef idx="1">
+            <a:schemeClr val="accent1"/>
+          </a:fillRef>
+          <a:effectRef idx="0">
+            <a:schemeClr val="accent1"/>
+          </a:effectRef>
+          <a:fontRef idx="minor">
+            <a:schemeClr val="lt1"/>
+          </a:fontRef>
+        </p:style>
+        <p:txBody>
+          <a:bodyPr rtlCol="0" anchor="ctr"/>
+          <a:lstStyle/>
+          <a:p>
+            <a:pPr algn="ctr"/>
+            <a:endParaRPr lang="en-NZ"/>
+          </a:p>
+        </p:txBody>
+      </p:sp>
+      <p:sp>
+        <p:nvSpPr>
+          <p:cNvPr id="3" name="TextBox 2">
+            <a:extLst>
+              <a:ext uri="{FF2B5EF4-FFF2-40B4-BE49-F238E27FC236}">
+                <a16:creationId xmlns:a16="http://schemas.microsoft.com/office/drawing/2014/main" id="{CF6C44CB-9B18-7C6C-F594-14E2357BDA83}"/>
+              </a:ext>
+            </a:extLst>
+          </p:cNvPr>
+          <p:cNvSpPr txBox="1"/>
+          <p:nvPr/>
+        </p:nvSpPr>
+        <p:spPr>
+          <a:xfrm>
+            <a:off x="6079914" y="3579292"/>
+            <a:ext cx="2482411" cy="646331"/>
+          </a:xfrm>
+          <a:prstGeom prst="rect">
+            <a:avLst/>
+          </a:prstGeom>
+          <a:noFill/>
+        </p:spPr>
+        <p:txBody>
+          <a:bodyPr wrap="none" rtlCol="0">
+            <a:spAutoFit/>
+          </a:bodyPr>
+          <a:lstStyle/>
+          <a:p>
+            <a:pPr algn="ctr"/>
+            <a:r>
+              <a:rPr lang="en-NZ" b="1" dirty="0"/>
+              <a:t>Evolutionary theory:</a:t>
+            </a:r>
+          </a:p>
+          <a:p>
+            <a:pPr algn="ctr"/>
+            <a:r>
+              <a:rPr lang="en-NZ" b="1" dirty="0"/>
+              <a:t>Extent of co-evolution</a:t>
+            </a:r>
+          </a:p>
+        </p:txBody>
+      </p:sp>
+      <p:sp>
+        <p:nvSpPr>
+          <p:cNvPr id="4" name="TextBox 3">
+            <a:extLst>
+              <a:ext uri="{FF2B5EF4-FFF2-40B4-BE49-F238E27FC236}">
+                <a16:creationId xmlns:a16="http://schemas.microsoft.com/office/drawing/2014/main" id="{EAA15363-E156-D932-2109-C258B1F8F449}"/>
+              </a:ext>
+            </a:extLst>
+          </p:cNvPr>
+          <p:cNvSpPr txBox="1"/>
+          <p:nvPr/>
+        </p:nvSpPr>
+        <p:spPr>
+          <a:xfrm>
+            <a:off x="6242137" y="2192506"/>
+            <a:ext cx="2157963" cy="646331"/>
+          </a:xfrm>
+          <a:prstGeom prst="rect">
+            <a:avLst/>
+          </a:prstGeom>
+          <a:noFill/>
+        </p:spPr>
+        <p:txBody>
+          <a:bodyPr wrap="none" rtlCol="0">
+            <a:spAutoFit/>
+          </a:bodyPr>
+          <a:lstStyle/>
+          <a:p>
+            <a:pPr algn="ctr"/>
+            <a:r>
+              <a:rPr lang="en-NZ" b="1" dirty="0"/>
+              <a:t>Ecological theory:</a:t>
+            </a:r>
+          </a:p>
+          <a:p>
+            <a:pPr algn="ctr"/>
+            <a:r>
+              <a:rPr lang="en-NZ" b="1" dirty="0"/>
+              <a:t>Recognition of Self</a:t>
+            </a:r>
+          </a:p>
+        </p:txBody>
+      </p:sp>
+      <p:sp>
+        <p:nvSpPr>
+          <p:cNvPr id="5" name="TextBox 4">
+            <a:extLst>
+              <a:ext uri="{FF2B5EF4-FFF2-40B4-BE49-F238E27FC236}">
+                <a16:creationId xmlns:a16="http://schemas.microsoft.com/office/drawing/2014/main" id="{8E6D3258-D691-A2F0-7922-4C7F833CC344}"/>
+              </a:ext>
+            </a:extLst>
+          </p:cNvPr>
+          <p:cNvSpPr txBox="1"/>
+          <p:nvPr/>
+        </p:nvSpPr>
+        <p:spPr>
+          <a:xfrm>
+            <a:off x="1954964" y="4639733"/>
+            <a:ext cx="8282075" cy="1200329"/>
+          </a:xfrm>
+          <a:prstGeom prst="rect">
+            <a:avLst/>
+          </a:prstGeom>
+          <a:noFill/>
+        </p:spPr>
+        <p:txBody>
+          <a:bodyPr wrap="none" rtlCol="0">
+            <a:spAutoFit/>
+          </a:bodyPr>
+          <a:lstStyle/>
+          <a:p>
+            <a:pPr algn="ctr"/>
+            <a:r>
+              <a:rPr lang="en-NZ" i="1" dirty="0"/>
+              <a:t>It is not a good idea to use both ecological and evolutionary theory, simultaneously,</a:t>
+            </a:r>
+          </a:p>
+          <a:p>
+            <a:pPr algn="ctr"/>
+            <a:r>
+              <a:rPr lang="en-NZ" i="1" dirty="0"/>
+              <a:t>to predict clinical phenotypes. This could lead to logical confounding.</a:t>
+            </a:r>
+          </a:p>
+          <a:p>
+            <a:pPr algn="ctr"/>
+            <a:endParaRPr lang="en-NZ" i="1" dirty="0"/>
+          </a:p>
+          <a:p>
+            <a:pPr algn="ctr"/>
+            <a:r>
+              <a:rPr lang="en-NZ" i="1" dirty="0"/>
+              <a:t>I want to focus on ecological theory, as it seems underexplored.</a:t>
+            </a:r>
+          </a:p>
+        </p:txBody>
+      </p:sp>
+      <p:sp>
+        <p:nvSpPr>
+          <p:cNvPr id="6" name="TextBox 5">
+            <a:extLst>
+              <a:ext uri="{FF2B5EF4-FFF2-40B4-BE49-F238E27FC236}">
+                <a16:creationId xmlns:a16="http://schemas.microsoft.com/office/drawing/2014/main" id="{8DD44F29-BEEC-1A69-0E0E-F6B2CDA8EA02}"/>
+              </a:ext>
+            </a:extLst>
+          </p:cNvPr>
+          <p:cNvSpPr txBox="1"/>
+          <p:nvPr/>
+        </p:nvSpPr>
+        <p:spPr>
+          <a:xfrm>
+            <a:off x="5952156" y="805721"/>
+            <a:ext cx="2737929" cy="646331"/>
+          </a:xfrm>
+          <a:prstGeom prst="rect">
+            <a:avLst/>
+          </a:prstGeom>
+          <a:noFill/>
+        </p:spPr>
+        <p:txBody>
+          <a:bodyPr wrap="none" rtlCol="0">
+            <a:spAutoFit/>
+          </a:bodyPr>
+          <a:lstStyle/>
+          <a:p>
+            <a:pPr algn="ctr"/>
+            <a:r>
+              <a:rPr lang="en-NZ" b="1" dirty="0"/>
+              <a:t>Molecular microbiology:</a:t>
+            </a:r>
+          </a:p>
+          <a:p>
+            <a:pPr algn="ctr"/>
+            <a:r>
+              <a:rPr lang="en-NZ" b="1" dirty="0"/>
+              <a:t>Biofilm phenotypes</a:t>
+            </a:r>
+          </a:p>
+        </p:txBody>
+      </p:sp>
+      <p:sp>
+        <p:nvSpPr>
+          <p:cNvPr id="7" name="TextBox 6">
+            <a:extLst>
+              <a:ext uri="{FF2B5EF4-FFF2-40B4-BE49-F238E27FC236}">
+                <a16:creationId xmlns:a16="http://schemas.microsoft.com/office/drawing/2014/main" id="{FEFF34A7-9146-08AB-9F2C-587F5A8731DF}"/>
+              </a:ext>
+            </a:extLst>
+          </p:cNvPr>
+          <p:cNvSpPr txBox="1"/>
+          <p:nvPr/>
+        </p:nvSpPr>
+        <p:spPr>
+          <a:xfrm rot="16200000">
+            <a:off x="3480248" y="2331006"/>
+            <a:ext cx="1310359" cy="369332"/>
+          </a:xfrm>
+          <a:prstGeom prst="rect">
+            <a:avLst/>
+          </a:prstGeom>
+          <a:noFill/>
+        </p:spPr>
+        <p:txBody>
+          <a:bodyPr wrap="none" rtlCol="0">
+            <a:spAutoFit/>
+          </a:bodyPr>
+          <a:lstStyle/>
+          <a:p>
+            <a:pPr algn="ctr"/>
+            <a:r>
+              <a:rPr lang="en-NZ" i="1" dirty="0"/>
+              <a:t>Complexity</a:t>
+            </a:r>
+          </a:p>
+        </p:txBody>
+      </p:sp>
+    </p:spTree>
+    <p:extLst>
+      <p:ext uri="{BB962C8B-B14F-4D97-AF65-F5344CB8AC3E}">
+        <p14:creationId xmlns:p14="http://schemas.microsoft.com/office/powerpoint/2010/main" val="1701025199"/>
       </p:ext>
     </p:extLst>
   </p:cSld>

</xml_diff>